<commit_message>
Pitch deck: reword chatbot positioning, clear resolved TODOs
Slide 2 positioning line now reads "We don't displace the chatbot. We
supplement it and interact with it." Removes the TODO markers on
Slide 14 (exit paths, comparable transactions) and on the appendix
competitor grid.
</commit_message>
<xml_diff>
--- a/pitch_deck/qlaudia_pitch_deck.pptx
+++ b/pitch_deck/qlaudia_pitch_deck.pptx
@@ -8858,7 +8858,7 @@
         <p:spPr>
           <a:xfrm>
             <a:off x="566928" y="1133856"/>
-            <a:ext cx="11057839" cy="376428"/>
+            <a:ext cx="11057839" cy="369189"/>
           </a:xfrm>
           <a:prstGeom prst="rect">
             <a:avLst/>
@@ -8872,40 +8872,6 @@
           <a:lstStyle/>
           <a:p>
             <a:r>
-              <a:rPr sz="1700" b="1" i="0">
-                <a:solidFill>
-                  <a:srgbClr val="C2410C"/>
-                </a:solidFill>
-                <a:latin typeface="Segoe UI"/>
-              </a:rPr>
-              <a:t>⚠️ TODO — the realistic exit paths.</a:t>
-            </a:r>
-          </a:p>
-        </p:txBody>
-      </p:sp>
-      <p:sp>
-        <p:nvSpPr>
-          <p:cNvPr id="5" name="TextBox 4"/>
-          <p:cNvSpPr txBox="1"/>
-          <p:nvPr/>
-        </p:nvSpPr>
-        <p:spPr>
-          <a:xfrm>
-            <a:off x="566928" y="1711452"/>
-            <a:ext cx="11057839" cy="369189"/>
-          </a:xfrm>
-          <a:prstGeom prst="rect">
-            <a:avLst/>
-          </a:prstGeom>
-          <a:noFill/>
-        </p:spPr>
-        <p:txBody>
-          <a:bodyPr wrap="square" lIns="0" rIns="0" tIns="0" bIns="0">
-            <a:spAutoFit/>
-          </a:bodyPr>
-          <a:lstStyle/>
-          <a:p>
-            <a:r>
               <a:rPr sz="1350" b="1" i="0">
                 <a:solidFill>
                   <a:srgbClr val="15192B"/>
@@ -8919,13 +8885,13 @@
       </p:sp>
       <p:sp>
         <p:nvSpPr>
-          <p:cNvPr id="6" name="Oval 5"/>
+          <p:cNvPr id="5" name="Oval 4"/>
           <p:cNvSpPr/>
           <p:nvPr/>
         </p:nvSpPr>
         <p:spPr>
           <a:xfrm>
-            <a:off x="585216" y="2159508"/>
+            <a:off x="585216" y="1581912"/>
             <a:ext cx="65836" cy="65836"/>
           </a:xfrm>
           <a:prstGeom prst="ellipse">
@@ -8963,13 +8929,13 @@
       </p:sp>
       <p:sp>
         <p:nvSpPr>
-          <p:cNvPr id="7" name="TextBox 6"/>
+          <p:cNvPr id="6" name="TextBox 5"/>
           <p:cNvSpPr txBox="1"/>
           <p:nvPr/>
         </p:nvSpPr>
         <p:spPr>
           <a:xfrm>
-            <a:off x="804672" y="2080641"/>
+            <a:off x="804672" y="1503045"/>
             <a:ext cx="10820095" cy="992124"/>
           </a:xfrm>
           <a:prstGeom prst="rect">
@@ -9024,13 +8990,13 @@
       </p:sp>
       <p:sp>
         <p:nvSpPr>
-          <p:cNvPr id="8" name="Oval 7"/>
+          <p:cNvPr id="7" name="Oval 6"/>
           <p:cNvSpPr/>
           <p:nvPr/>
         </p:nvSpPr>
         <p:spPr>
           <a:xfrm>
-            <a:off x="585216" y="3151632"/>
+            <a:off x="585216" y="2574036"/>
             <a:ext cx="65836" cy="65836"/>
           </a:xfrm>
           <a:prstGeom prst="ellipse">
@@ -9068,13 +9034,13 @@
       </p:sp>
       <p:sp>
         <p:nvSpPr>
-          <p:cNvPr id="9" name="TextBox 8"/>
+          <p:cNvPr id="8" name="TextBox 7"/>
           <p:cNvSpPr txBox="1"/>
           <p:nvPr/>
         </p:nvSpPr>
         <p:spPr>
           <a:xfrm>
-            <a:off x="804672" y="3072765"/>
+            <a:off x="804672" y="2495169"/>
             <a:ext cx="10820095" cy="546354"/>
           </a:xfrm>
           <a:prstGeom prst="rect">
@@ -9111,13 +9077,13 @@
       </p:sp>
       <p:sp>
         <p:nvSpPr>
-          <p:cNvPr id="10" name="Oval 9"/>
+          <p:cNvPr id="9" name="Oval 8"/>
           <p:cNvSpPr/>
           <p:nvPr/>
         </p:nvSpPr>
         <p:spPr>
           <a:xfrm>
-            <a:off x="585216" y="3697986"/>
+            <a:off x="585216" y="3120390"/>
             <a:ext cx="65836" cy="65836"/>
           </a:xfrm>
           <a:prstGeom prst="ellipse">
@@ -9155,13 +9121,13 @@
       </p:sp>
       <p:sp>
         <p:nvSpPr>
-          <p:cNvPr id="11" name="TextBox 10"/>
+          <p:cNvPr id="10" name="TextBox 9"/>
           <p:cNvSpPr txBox="1"/>
           <p:nvPr/>
         </p:nvSpPr>
         <p:spPr>
           <a:xfrm>
-            <a:off x="804672" y="3619119"/>
+            <a:off x="804672" y="3041523"/>
             <a:ext cx="10820095" cy="323469"/>
           </a:xfrm>
           <a:prstGeom prst="rect">
@@ -9198,13 +9164,13 @@
       </p:sp>
       <p:sp>
         <p:nvSpPr>
-          <p:cNvPr id="12" name="Oval 11"/>
+          <p:cNvPr id="11" name="Oval 10"/>
           <p:cNvSpPr/>
           <p:nvPr/>
         </p:nvSpPr>
         <p:spPr>
           <a:xfrm>
-            <a:off x="585216" y="4021454"/>
+            <a:off x="585216" y="3443859"/>
             <a:ext cx="65836" cy="65836"/>
           </a:xfrm>
           <a:prstGeom prst="ellipse">
@@ -9242,13 +9208,13 @@
       </p:sp>
       <p:sp>
         <p:nvSpPr>
-          <p:cNvPr id="13" name="TextBox 12"/>
+          <p:cNvPr id="12" name="TextBox 11"/>
           <p:cNvSpPr txBox="1"/>
           <p:nvPr/>
         </p:nvSpPr>
         <p:spPr>
           <a:xfrm>
-            <a:off x="804672" y="3942588"/>
+            <a:off x="804672" y="3364992"/>
             <a:ext cx="10820095" cy="323469"/>
           </a:xfrm>
           <a:prstGeom prst="rect">
@@ -9285,13 +9251,13 @@
       </p:sp>
       <p:sp>
         <p:nvSpPr>
-          <p:cNvPr id="14" name="Oval 13"/>
+          <p:cNvPr id="13" name="Oval 12"/>
           <p:cNvSpPr/>
           <p:nvPr/>
         </p:nvSpPr>
         <p:spPr>
           <a:xfrm>
-            <a:off x="585216" y="4344923"/>
+            <a:off x="585216" y="3767328"/>
             <a:ext cx="65836" cy="65836"/>
           </a:xfrm>
           <a:prstGeom prst="ellipse">
@@ -9329,13 +9295,13 @@
       </p:sp>
       <p:sp>
         <p:nvSpPr>
-          <p:cNvPr id="15" name="TextBox 14"/>
+          <p:cNvPr id="14" name="TextBox 13"/>
           <p:cNvSpPr txBox="1"/>
           <p:nvPr/>
         </p:nvSpPr>
         <p:spPr>
           <a:xfrm>
-            <a:off x="804672" y="4266057"/>
+            <a:off x="804672" y="3688461"/>
             <a:ext cx="10820095" cy="323469"/>
           </a:xfrm>
           <a:prstGeom prst="rect">
@@ -9372,13 +9338,13 @@
       </p:sp>
       <p:sp>
         <p:nvSpPr>
-          <p:cNvPr id="16" name="Oval 15"/>
+          <p:cNvPr id="15" name="Oval 14"/>
           <p:cNvSpPr/>
           <p:nvPr/>
         </p:nvSpPr>
         <p:spPr>
           <a:xfrm>
-            <a:off x="585216" y="4668392"/>
+            <a:off x="585216" y="4090797"/>
             <a:ext cx="65836" cy="65836"/>
           </a:xfrm>
           <a:prstGeom prst="ellipse">
@@ -9416,13 +9382,13 @@
       </p:sp>
       <p:sp>
         <p:nvSpPr>
-          <p:cNvPr id="17" name="TextBox 16"/>
+          <p:cNvPr id="16" name="TextBox 15"/>
           <p:cNvSpPr txBox="1"/>
           <p:nvPr/>
         </p:nvSpPr>
         <p:spPr>
           <a:xfrm>
-            <a:off x="804672" y="4589525"/>
+            <a:off x="804672" y="4011930"/>
             <a:ext cx="10820095" cy="323469"/>
           </a:xfrm>
           <a:prstGeom prst="rect">
@@ -9453,84 +9419,6 @@
                 <a:latin typeface="Segoe UI"/>
               </a:rPr>
               <a:t> — Microsoft, Google (Classroom / Workspace for Education)</a:t>
-            </a:r>
-          </a:p>
-        </p:txBody>
-      </p:sp>
-      <p:sp>
-        <p:nvSpPr>
-          <p:cNvPr id="18" name="Oval 17"/>
-          <p:cNvSpPr/>
-          <p:nvPr/>
-        </p:nvSpPr>
-        <p:spPr>
-          <a:xfrm>
-            <a:off x="585216" y="4991861"/>
-            <a:ext cx="65836" cy="65836"/>
-          </a:xfrm>
-          <a:prstGeom prst="ellipse">
-            <a:avLst/>
-          </a:prstGeom>
-          <a:solidFill>
-            <a:srgbClr val="4A3AFF"/>
-          </a:solidFill>
-          <a:ln>
-            <a:noFill/>
-          </a:ln>
-          <a:effectLst/>
-        </p:spPr>
-        <p:style>
-          <a:lnRef idx="1">
-            <a:schemeClr val="accent1"/>
-          </a:lnRef>
-          <a:fillRef idx="3">
-            <a:schemeClr val="accent1"/>
-          </a:fillRef>
-          <a:effectRef idx="2">
-            <a:schemeClr val="accent1"/>
-          </a:effectRef>
-          <a:fontRef idx="minor">
-            <a:schemeClr val="lt1"/>
-          </a:fontRef>
-        </p:style>
-        <p:txBody>
-          <a:bodyPr rtlCol="0" anchor="ctr"/>
-          <a:lstStyle/>
-          <a:p>
-            <a:pPr algn="ctr"/>
-          </a:p>
-        </p:txBody>
-      </p:sp>
-      <p:sp>
-        <p:nvSpPr>
-          <p:cNvPr id="19" name="TextBox 18"/>
-          <p:cNvSpPr txBox="1"/>
-          <p:nvPr/>
-        </p:nvSpPr>
-        <p:spPr>
-          <a:xfrm>
-            <a:off x="804672" y="4912994"/>
-            <a:ext cx="10820095" cy="323469"/>
-          </a:xfrm>
-          <a:prstGeom prst="rect">
-            <a:avLst/>
-          </a:prstGeom>
-          <a:noFill/>
-        </p:spPr>
-        <p:txBody>
-          <a:bodyPr wrap="square" lIns="0" rIns="0" tIns="0" bIns="0">
-            <a:spAutoFit/>
-          </a:bodyPr>
-          <a:lstStyle/>
-          <a:p>
-            <a:r>
-              <a:rPr sz="1350" b="0" i="0">
-                <a:solidFill>
-                  <a:srgbClr val="C2410C"/>
-                </a:solidFill>
-                <a:latin typeface="Segoe UI"/>
-              </a:rPr>
-              <a:t>⚠️ TODO: comparable transactions and multiples in this space</a:t>
             </a:r>
           </a:p>
         </p:txBody>
@@ -10129,84 +10017,6 @@
                 <a:latin typeface="Segoe UI"/>
               </a:rPr>
               <a:t> (Pearson, McGraw Hill, Cengage) — own the content, but it's manually produced and static</a:t>
-            </a:r>
-          </a:p>
-        </p:txBody>
-      </p:sp>
-      <p:sp>
-        <p:nvSpPr>
-          <p:cNvPr id="13" name="Rectangle 12"/>
-          <p:cNvSpPr/>
-          <p:nvPr/>
-        </p:nvSpPr>
-        <p:spPr>
-          <a:xfrm>
-            <a:off x="566928" y="3270122"/>
-            <a:ext cx="50292" cy="698754"/>
-          </a:xfrm>
-          <a:prstGeom prst="rect">
-            <a:avLst/>
-          </a:prstGeom>
-          <a:solidFill>
-            <a:srgbClr val="4A3AFF"/>
-          </a:solidFill>
-          <a:ln>
-            <a:noFill/>
-          </a:ln>
-          <a:effectLst/>
-        </p:spPr>
-        <p:style>
-          <a:lnRef idx="1">
-            <a:schemeClr val="accent1"/>
-          </a:lnRef>
-          <a:fillRef idx="3">
-            <a:schemeClr val="accent1"/>
-          </a:fillRef>
-          <a:effectRef idx="2">
-            <a:schemeClr val="accent1"/>
-          </a:effectRef>
-          <a:fontRef idx="minor">
-            <a:schemeClr val="lt1"/>
-          </a:fontRef>
-        </p:style>
-        <p:txBody>
-          <a:bodyPr rtlCol="0" anchor="ctr"/>
-          <a:lstStyle/>
-          <a:p>
-            <a:pPr algn="ctr"/>
-          </a:p>
-        </p:txBody>
-      </p:sp>
-      <p:sp>
-        <p:nvSpPr>
-          <p:cNvPr id="14" name="TextBox 13"/>
-          <p:cNvSpPr txBox="1"/>
-          <p:nvPr/>
-        </p:nvSpPr>
-        <p:spPr>
-          <a:xfrm>
-            <a:off x="877824" y="3242690"/>
-            <a:ext cx="10746943" cy="790194"/>
-          </a:xfrm>
-          <a:prstGeom prst="rect">
-            <a:avLst/>
-          </a:prstGeom>
-          <a:noFill/>
-        </p:spPr>
-        <p:txBody>
-          <a:bodyPr wrap="square" lIns="0" rIns="0" tIns="0" bIns="0">
-            <a:spAutoFit/>
-          </a:bodyPr>
-          <a:lstStyle/>
-          <a:p>
-            <a:r>
-              <a:rPr sz="1300" b="0" i="1">
-                <a:solidFill>
-                  <a:srgbClr val="C2410C"/>
-                </a:solidFill>
-                <a:latin typeface="Segoe UI"/>
-              </a:rPr>
-              <a:t>⚠️ TODO: Charles to confirm which competitors actually come up in his conversations. Moved out of the main deck for angels — the named-competitor grid is a VC-diligence artifact, and the differentiation argument is already carried by Slides 2, 3, and 6. Bring it back into the main deck if a specific investor asks.</a:t>
             </a:r>
           </a:p>
         </p:txBody>

</xml_diff>